<commit_message>
fix: poster size 120x90cm landscape, 3-column layout
Resized from A1 portrait to 120x90cm landscape.
Layout: title bar + 2 rows × 3 columns + bottom bar.
All 5 figures + background text + database summary
positioned in a balanced 3-column grid.
</commit_message>
<xml_diff>
--- a/report/poster.pptx
+++ b/report/poster.pptx
@@ -7,7 +7,7 @@
   <p:sldIdLst>
     <p:sldId id="256" r:id="rId7"/>
   </p:sldIdLst>
-  <p:sldSz cx="21384000" cy="30275999" type="screen4x3"/>
+  <p:sldSz cx="43200000" cy="32400000" type="screen4x3"/>
   <p:notesSz cx="6858000" cy="9144000"/>
   <p:defaultTextStyle>
     <a:defPPr>
@@ -3096,8 +3096,8 @@
         </p:nvSpPr>
         <p:spPr>
           <a:xfrm>
-            <a:off x="360000" y="360000"/>
-            <a:ext cx="20664000" cy="1620000"/>
+            <a:off x="720000" y="540000"/>
+            <a:ext cx="41760000" cy="2520000"/>
           </a:xfrm>
           <a:prstGeom prst="roundRect">
             <a:avLst/>
@@ -3139,8 +3139,8 @@
         </p:nvSpPr>
         <p:spPr>
           <a:xfrm>
-            <a:off x="720000" y="468000"/>
-            <a:ext cx="19800000" cy="900000"/>
+            <a:off x="1440000" y="720000"/>
+            <a:ext cx="40320000" cy="1260000"/>
           </a:xfrm>
           <a:prstGeom prst="rect">
             <a:avLst/>
@@ -3154,14 +3154,18 @@
           <a:lstStyle/>
           <a:p>
             <a:pPr algn="ctr">
-              <a:defRPr sz="2800" b="1">
+              <a:defRPr sz="3600" b="1">
                 <a:solidFill>
                   <a:srgbClr val="FFFFFF"/>
                 </a:solidFill>
               </a:defRPr>
             </a:pPr>
             <a:r>
-              <a:t>SubCellSpace: A Unified Database for Subcellular Spatial Transcriptomics</a:t>
+              <a:t>SubCellSpace: A Unified Database for</a:t>
+            </a:r>
+            <a:br/>
+            <a:r>
+              <a:t>Subcellular Spatial Transcriptomics</a:t>
             </a:r>
           </a:p>
         </p:txBody>
@@ -3174,8 +3178,8 @@
         </p:nvSpPr>
         <p:spPr>
           <a:xfrm>
-            <a:off x="720000" y="1260000"/>
-            <a:ext cx="19800000" cy="540000"/>
+            <a:off x="1440000" y="1980000"/>
+            <a:ext cx="40320000" cy="540000"/>
           </a:xfrm>
           <a:prstGeom prst="rect">
             <a:avLst/>
@@ -3189,7 +3193,7 @@
           <a:lstStyle/>
           <a:p>
             <a:pPr algn="ctr">
-              <a:defRPr sz="1200" b="0">
+              <a:defRPr sz="1400" b="0">
                 <a:solidFill>
                   <a:srgbClr val="BDC3C7"/>
                 </a:solidFill>
@@ -3209,8 +3213,8 @@
         </p:nvSpPr>
         <p:spPr>
           <a:xfrm>
-            <a:off x="540000" y="2340000"/>
-            <a:ext cx="9720000" cy="1980000"/>
+            <a:off x="720000" y="3420000"/>
+            <a:ext cx="13320000" cy="3240000"/>
           </a:xfrm>
           <a:prstGeom prst="roundRect">
             <a:avLst/>
@@ -3252,8 +3256,8 @@
         </p:nvSpPr>
         <p:spPr>
           <a:xfrm>
-            <a:off x="900000" y="2448000"/>
-            <a:ext cx="9000000" cy="288000"/>
+            <a:off x="1080000" y="3528000"/>
+            <a:ext cx="12600000" cy="360000"/>
           </a:xfrm>
           <a:prstGeom prst="rect">
             <a:avLst/>
@@ -3267,7 +3271,7 @@
           <a:lstStyle/>
           <a:p>
             <a:pPr algn="l">
-              <a:defRPr sz="1600" b="1">
+              <a:defRPr sz="2000" b="1">
                 <a:solidFill>
                   <a:srgbClr val="2C3E50"/>
                 </a:solidFill>
@@ -3287,8 +3291,8 @@
         </p:nvSpPr>
         <p:spPr>
           <a:xfrm>
-            <a:off x="900000" y="2808000"/>
-            <a:ext cx="9000000" cy="1440000"/>
+            <a:off x="1080000" y="3960000"/>
+            <a:ext cx="12600000" cy="2520000"/>
           </a:xfrm>
           <a:prstGeom prst="rect">
             <a:avLst/>
@@ -3302,7 +3306,7 @@
           <a:lstStyle/>
           <a:p>
             <a:pPr algn="l">
-              <a:defRPr sz="900" b="0">
+              <a:defRPr sz="1200" b="0">
                 <a:solidFill>
                   <a:srgbClr val="2C3E50"/>
                 </a:solidFill>
@@ -3320,16 +3324,26 @@
               <a:t>scverse-native database from three major platforms:</a:t>
             </a:r>
             <a:br/>
+            <a:br/>
             <a:r>
               <a:t>  • NanoString CosMx — High-plex in situ RNA detection</a:t>
             </a:r>
             <a:br/>
             <a:r>
-              <a:t>  • 10x Genomics Xenium — Subcellular + multi-modal imaging</a:t>
+              <a:t>  • 10x Genomics Xenium — Subcellular + multimodal imaging</a:t>
             </a:r>
             <a:br/>
             <a:r>
-              <a:t>  • Vizgen MERFISH — Multiplexed FISH with ultra-high plexity</a:t>
+              <a:t>  • Vizgen MERFISH — Multiplexed FISH, ultra-high plexity</a:t>
+            </a:r>
+            <a:br/>
+            <a:br/>
+            <a:r>
+              <a:t>All data processed through a unified 6-step pipeline with</a:t>
+            </a:r>
+            <a:br/>
+            <a:r>
+              <a:t>21 standardized metadata columns per entry.</a:t>
             </a:r>
           </a:p>
         </p:txBody>
@@ -3342,8 +3356,8 @@
         </p:nvSpPr>
         <p:spPr>
           <a:xfrm>
-            <a:off x="540000" y="4500000"/>
-            <a:ext cx="9720000" cy="3060000"/>
+            <a:off x="720000" y="18720000"/>
+            <a:ext cx="13320000" cy="12240000"/>
           </a:xfrm>
           <a:prstGeom prst="roundRect">
             <a:avLst/>
@@ -3385,8 +3399,8 @@
         </p:nvSpPr>
         <p:spPr>
           <a:xfrm>
-            <a:off x="900000" y="4608000"/>
-            <a:ext cx="9000000" cy="288000"/>
+            <a:off x="1080000" y="18828000"/>
+            <a:ext cx="12600000" cy="360000"/>
           </a:xfrm>
           <a:prstGeom prst="rect">
             <a:avLst/>
@@ -3400,7 +3414,7 @@
           <a:lstStyle/>
           <a:p>
             <a:pPr algn="l">
-              <a:defRPr sz="1600" b="1">
+              <a:defRPr sz="2000" b="1">
                 <a:solidFill>
                   <a:srgbClr val="2C3E50"/>
                 </a:solidFill>
@@ -3428,8 +3442,8 @@
         </p:blipFill>
         <p:spPr>
           <a:xfrm>
-            <a:off x="720000" y="5040000"/>
-            <a:ext cx="9360000" cy="2340000"/>
+            <a:off x="900000" y="19440000"/>
+            <a:ext cx="12960000" cy="5040000"/>
           </a:xfrm>
           <a:prstGeom prst="rect">
             <a:avLst/>
@@ -3444,14 +3458,14 @@
         </p:nvSpPr>
         <p:spPr>
           <a:xfrm>
-            <a:off x="10800000" y="2340000"/>
-            <a:ext cx="10080000" cy="4680000"/>
+            <a:off x="900000" y="24660000"/>
+            <a:ext cx="12960000" cy="5760000"/>
           </a:xfrm>
           <a:prstGeom prst="roundRect">
             <a:avLst/>
           </a:prstGeom>
           <a:solidFill>
-            <a:srgbClr val="FFFFFF"/>
+            <a:srgbClr val="E8F8F0"/>
           </a:solidFill>
           <a:ln>
             <a:noFill/>
@@ -3487,8 +3501,8 @@
         </p:nvSpPr>
         <p:spPr>
           <a:xfrm>
-            <a:off x="11160000" y="2448000"/>
-            <a:ext cx="9360000" cy="288000"/>
+            <a:off x="1260000" y="24840000"/>
+            <a:ext cx="12600000" cy="5400000"/>
           </a:xfrm>
           <a:prstGeom prst="rect">
             <a:avLst/>
@@ -3502,58 +3516,72 @@
           <a:lstStyle/>
           <a:p>
             <a:pPr algn="l">
-              <a:defRPr sz="1600" b="1">
+              <a:defRPr sz="1200" b="0">
                 <a:solidFill>
                   <a:srgbClr val="2C3E50"/>
                 </a:solidFill>
               </a:defRPr>
             </a:pPr>
             <a:r>
-              <a:t>Database Scale &amp; Enrichment</a:t>
-            </a:r>
-          </a:p>
-        </p:txBody>
-      </p:sp>
-      <p:pic>
-        <p:nvPicPr>
-          <p:cNvPr id="13" name="Picture 12" descr="fig1_overview.png"/>
-          <p:cNvPicPr>
-            <a:picLocks noChangeAspect="1"/>
-          </p:cNvPicPr>
-          <p:nvPr/>
-        </p:nvPicPr>
-        <p:blipFill>
-          <a:blip r:embed="rId3"/>
-          <a:stretch>
-            <a:fillRect/>
-          </a:stretch>
-        </p:blipFill>
-        <p:spPr>
-          <a:xfrm>
-            <a:off x="10908000" y="2880000"/>
-            <a:ext cx="9864000" cy="3960000"/>
-          </a:xfrm>
-          <a:prstGeom prst="rect">
-            <a:avLst/>
-          </a:prstGeom>
-        </p:spPr>
-      </p:pic>
-      <p:sp>
-        <p:nvSpPr>
-          <p:cNvPr id="14" name="Rounded Rectangle 13"/>
+              <a:t>Database Summary</a:t>
+            </a:r>
+            <a:br/>
+            <a:br/>
+            <a:r>
+              <a:t>Total datasets indexed:      2,131</a:t>
+            </a:r>
+            <a:br/>
+            <a:r>
+              <a:t>Ready for analysis:            1,019</a:t>
+            </a:r>
+            <a:br/>
+            <a:r>
+              <a:t>Pending download:             1,055</a:t>
+            </a:r>
+            <a:br/>
+            <a:r>
+              <a:t>Platform breakdown:</a:t>
+            </a:r>
+            <a:br/>
+            <a:r>
+              <a:t>  CosMx   476  (186 ready)</a:t>
+            </a:r>
+            <a:br/>
+            <a:r>
+              <a:t>  Xenium  1,525 (717 ready)</a:t>
+            </a:r>
+            <a:br/>
+            <a:r>
+              <a:t>  MERFISH 130   (116 ready)</a:t>
+            </a:r>
+            <a:br/>
+            <a:br/>
+            <a:r>
+              <a:t>Each entry: 21 columns (GEO metadata,</a:t>
+            </a:r>
+            <a:br/>
+            <a:r>
+              <a:t>LLM annotation, file info, statistics)</a:t>
+            </a:r>
+          </a:p>
+        </p:txBody>
+      </p:sp>
+      <p:sp>
+        <p:nvSpPr>
+          <p:cNvPr id="13" name="Rounded Rectangle 12"/>
           <p:cNvSpPr/>
           <p:nvPr/>
         </p:nvSpPr>
         <p:spPr>
           <a:xfrm>
-            <a:off x="10800000" y="7200000"/>
-            <a:ext cx="10080000" cy="1260000"/>
+            <a:off x="14760000" y="3420000"/>
+            <a:ext cx="13320000" cy="13680000"/>
           </a:xfrm>
           <a:prstGeom prst="roundRect">
             <a:avLst/>
           </a:prstGeom>
           <a:solidFill>
-            <a:srgbClr val="E8F8F0"/>
+            <a:srgbClr val="FFFFFF"/>
           </a:solidFill>
           <a:ln>
             <a:noFill/>
@@ -3583,14 +3611,14 @@
       </p:sp>
       <p:sp>
         <p:nvSpPr>
-          <p:cNvPr id="15" name="TextBox 14"/>
+          <p:cNvPr id="14" name="TextBox 13"/>
           <p:cNvSpPr txBox="1"/>
           <p:nvPr/>
         </p:nvSpPr>
         <p:spPr>
           <a:xfrm>
-            <a:off x="11160000" y="7380000"/>
-            <a:ext cx="9360000" cy="900000"/>
+            <a:off x="15120000" y="3528000"/>
+            <a:ext cx="12600000" cy="360000"/>
           </a:xfrm>
           <a:prstGeom prst="rect">
             <a:avLst/>
@@ -3604,34 +3632,42 @@
           <a:lstStyle/>
           <a:p>
             <a:pPr algn="l">
-              <a:defRPr sz="1000" b="0">
+              <a:defRPr sz="2000" b="1">
                 <a:solidFill>
                   <a:srgbClr val="2C3E50"/>
                 </a:solidFill>
               </a:defRPr>
             </a:pPr>
             <a:r>
-              <a:t>Database Summary</a:t>
-            </a:r>
-            <a:br/>
-            <a:r>
-              <a:t>Total datasets: 2,131  |  Ready: 1,019</a:t>
-            </a:r>
-            <a:br/>
-            <a:r>
-              <a:t>CosMx: 476  |  Xenium: 1,525  |  MERFISH: 130</a:t>
-            </a:r>
-            <a:br/>
-            <a:r>
-              <a:t>21 data columns per entry: GEO metadata + LLM annotation</a:t>
-            </a:r>
-            <a:br/>
-            <a:r>
-              <a:t>+ file integrity (touch) + streaming statistics</a:t>
-            </a:r>
-          </a:p>
-        </p:txBody>
-      </p:sp>
+              <a:t>Database Scale &amp; Data Enrichment</a:t>
+            </a:r>
+          </a:p>
+        </p:txBody>
+      </p:sp>
+      <p:pic>
+        <p:nvPicPr>
+          <p:cNvPr id="15" name="Picture 14" descr="fig1_overview.png"/>
+          <p:cNvPicPr>
+            <a:picLocks noChangeAspect="1"/>
+          </p:cNvPicPr>
+          <p:nvPr/>
+        </p:nvPicPr>
+        <p:blipFill>
+          <a:blip r:embed="rId3"/>
+          <a:stretch>
+            <a:fillRect/>
+          </a:stretch>
+        </p:blipFill>
+        <p:spPr>
+          <a:xfrm>
+            <a:off x="14868000" y="4068000"/>
+            <a:ext cx="13104000" cy="12600000"/>
+          </a:xfrm>
+          <a:prstGeom prst="rect">
+            <a:avLst/>
+          </a:prstGeom>
+        </p:spPr>
+      </p:pic>
       <p:sp>
         <p:nvSpPr>
           <p:cNvPr id="16" name="Rounded Rectangle 15"/>
@@ -3640,8 +3676,8 @@
         </p:nvSpPr>
         <p:spPr>
           <a:xfrm>
-            <a:off x="10800000" y="8640000"/>
-            <a:ext cx="10080000" cy="3060000"/>
+            <a:off x="14760000" y="18720000"/>
+            <a:ext cx="13320000" cy="12240000"/>
           </a:xfrm>
           <a:prstGeom prst="roundRect">
             <a:avLst/>
@@ -3683,8 +3719,8 @@
         </p:nvSpPr>
         <p:spPr>
           <a:xfrm>
-            <a:off x="11160000" y="8748000"/>
-            <a:ext cx="9360000" cy="288000"/>
+            <a:off x="15120000" y="18828000"/>
+            <a:ext cx="12600000" cy="360000"/>
           </a:xfrm>
           <a:prstGeom prst="rect">
             <a:avLst/>
@@ -3698,7 +3734,7 @@
           <a:lstStyle/>
           <a:p>
             <a:pPr algn="l">
-              <a:defRPr sz="1600" b="1">
+              <a:defRPr sz="2000" b="1">
                 <a:solidFill>
                   <a:srgbClr val="2C3E50"/>
                 </a:solidFill>
@@ -3726,8 +3762,8 @@
         </p:blipFill>
         <p:spPr>
           <a:xfrm>
-            <a:off x="10908000" y="9180000"/>
-            <a:ext cx="9864000" cy="2340000"/>
+            <a:off x="14868000" y="19368000"/>
+            <a:ext cx="13104000" cy="11160000"/>
           </a:xfrm>
           <a:prstGeom prst="rect">
             <a:avLst/>
@@ -3742,8 +3778,8 @@
         </p:nvSpPr>
         <p:spPr>
           <a:xfrm>
-            <a:off x="540000" y="7740000"/>
-            <a:ext cx="9720000" cy="3780000"/>
+            <a:off x="28800000" y="3420000"/>
+            <a:ext cx="13320000" cy="13680000"/>
           </a:xfrm>
           <a:prstGeom prst="roundRect">
             <a:avLst/>
@@ -3785,8 +3821,8 @@
         </p:nvSpPr>
         <p:spPr>
           <a:xfrm>
-            <a:off x="900000" y="7848000"/>
-            <a:ext cx="9000000" cy="288000"/>
+            <a:off x="29160000" y="3528000"/>
+            <a:ext cx="12600000" cy="360000"/>
           </a:xfrm>
           <a:prstGeom prst="rect">
             <a:avLst/>
@@ -3800,7 +3836,7 @@
           <a:lstStyle/>
           <a:p>
             <a:pPr algn="l">
-              <a:defRPr sz="1600" b="1">
+              <a:defRPr sz="2000" b="1">
                 <a:solidFill>
                   <a:srgbClr val="2C3E50"/>
                 </a:solidFill>
@@ -3828,8 +3864,8 @@
         </p:blipFill>
         <p:spPr>
           <a:xfrm>
-            <a:off x="648000" y="8280000"/>
-            <a:ext cx="9504000" cy="3060000"/>
+            <a:off x="28908000" y="4068000"/>
+            <a:ext cx="13104000" cy="12600000"/>
           </a:xfrm>
           <a:prstGeom prst="rect">
             <a:avLst/>
@@ -3844,8 +3880,8 @@
         </p:nvSpPr>
         <p:spPr>
           <a:xfrm>
-            <a:off x="540000" y="11700000"/>
-            <a:ext cx="9720000" cy="3780000"/>
+            <a:off x="28800000" y="18720000"/>
+            <a:ext cx="13320000" cy="12240000"/>
           </a:xfrm>
           <a:prstGeom prst="roundRect">
             <a:avLst/>
@@ -3887,8 +3923,8 @@
         </p:nvSpPr>
         <p:spPr>
           <a:xfrm>
-            <a:off x="900000" y="11808000"/>
-            <a:ext cx="9000000" cy="288000"/>
+            <a:off x="29160000" y="18828000"/>
+            <a:ext cx="12600000" cy="360000"/>
           </a:xfrm>
           <a:prstGeom prst="rect">
             <a:avLst/>
@@ -3902,7 +3938,7 @@
           <a:lstStyle/>
           <a:p>
             <a:pPr algn="l">
-              <a:defRPr sz="1600" b="1">
+              <a:defRPr sz="2000" b="1">
                 <a:solidFill>
                   <a:srgbClr val="2C3E50"/>
                 </a:solidFill>
@@ -3930,8 +3966,8 @@
         </p:blipFill>
         <p:spPr>
           <a:xfrm>
-            <a:off x="648000" y="12240000"/>
-            <a:ext cx="9504000" cy="3060000"/>
+            <a:off x="28908000" y="19368000"/>
+            <a:ext cx="13104000" cy="11160000"/>
           </a:xfrm>
           <a:prstGeom prst="rect">
             <a:avLst/>
@@ -3946,8 +3982,8 @@
         </p:nvSpPr>
         <p:spPr>
           <a:xfrm>
-            <a:off x="360000" y="28980000"/>
-            <a:ext cx="20664000" cy="900000"/>
+            <a:off x="720000" y="31320000"/>
+            <a:ext cx="41760000" cy="900000"/>
           </a:xfrm>
           <a:prstGeom prst="roundRect">
             <a:avLst/>
@@ -3989,8 +4025,8 @@
         </p:nvSpPr>
         <p:spPr>
           <a:xfrm>
-            <a:off x="720000" y="29160000"/>
-            <a:ext cx="19800000" cy="540000"/>
+            <a:off x="1440000" y="31500000"/>
+            <a:ext cx="40320000" cy="540000"/>
           </a:xfrm>
           <a:prstGeom prst="rect">
             <a:avLst/>
@@ -4004,7 +4040,7 @@
           <a:lstStyle/>
           <a:p>
             <a:pPr algn="ctr">
-              <a:defRPr sz="1000" b="0">
+              <a:defRPr sz="1100" b="0">
                 <a:solidFill>
                   <a:srgbClr val="BDC3C7"/>
                 </a:solidFill>
@@ -4015,7 +4051,7 @@
             </a:r>
             <a:br/>
             <a:r>
-              <a:t>Data: NCBI GEO · DeepSeek LLM · 10x Genomics · NanoString/Bruker · Vizgen</a:t>
+              <a:t>Data Sources: NCBI GEO · DeepSeek LLM · 10x Genomics · NanoString/Bruker · Vizgen</a:t>
             </a:r>
           </a:p>
         </p:txBody>

</xml_diff>

<commit_message>
feat: comprehensive poster covering full project scope
7 sections, 90x120cm portrait:
1. Project Overview — 3 platforms, 3 components
2. Analysis Pipeline — 6-step diagram
3. Pipeline Steps — all backends per step
4. GEO Database — dual architecture, 4-step enrichment
5. Database Statistics — tissue/disease + CosMx histograms
6. File Coverage & Frontend — companion files + React browser
7. System Architecture — core stack, tools, infrastructure

30 shapes, 4 figures, 615 KB
</commit_message>
<xml_diff>
--- a/report/poster.pptx
+++ b/report/poster.pptx
@@ -7,7 +7,7 @@
   <p:sldIdLst>
     <p:sldId id="256" r:id="rId7"/>
   </p:sldIdLst>
-  <p:sldSz cx="43200000" cy="32400000" type="screen4x3"/>
+  <p:sldSz cx="32400000" cy="43200000" type="screen4x3"/>
   <p:notesSz cx="6858000" cy="9144000"/>
   <p:defaultTextStyle>
     <a:defPPr>
@@ -3097,7 +3097,7 @@
         <p:spPr>
           <a:xfrm>
             <a:off x="720000" y="540000"/>
-            <a:ext cx="41760000" cy="2520000"/>
+            <a:ext cx="30960000" cy="2700000"/>
           </a:xfrm>
           <a:prstGeom prst="roundRect">
             <a:avLst/>
@@ -3139,8 +3139,8 @@
         </p:nvSpPr>
         <p:spPr>
           <a:xfrm>
-            <a:off x="1440000" y="720000"/>
-            <a:ext cx="40320000" cy="1260000"/>
+            <a:off x="1080000" y="720000"/>
+            <a:ext cx="30240000" cy="1260000"/>
           </a:xfrm>
           <a:prstGeom prst="rect">
             <a:avLst/>
@@ -3154,7 +3154,7 @@
           <a:lstStyle/>
           <a:p>
             <a:pPr algn="ctr">
-              <a:defRPr sz="3600" b="1">
+              <a:defRPr sz="3200" b="1">
                 <a:solidFill>
                   <a:srgbClr val="FFFFFF"/>
                 </a:solidFill>
@@ -3178,8 +3178,8 @@
         </p:nvSpPr>
         <p:spPr>
           <a:xfrm>
-            <a:off x="1440000" y="1980000"/>
-            <a:ext cx="40320000" cy="540000"/>
+            <a:off x="1080000" y="2160000"/>
+            <a:ext cx="30240000" cy="540000"/>
           </a:xfrm>
           <a:prstGeom prst="rect">
             <a:avLst/>
@@ -3213,8 +3213,8 @@
         </p:nvSpPr>
         <p:spPr>
           <a:xfrm>
-            <a:off x="720000" y="3420000"/>
-            <a:ext cx="13320000" cy="3240000"/>
+            <a:off x="720000" y="3600000"/>
+            <a:ext cx="15120000" cy="4680000"/>
           </a:xfrm>
           <a:prstGeom prst="roundRect">
             <a:avLst/>
@@ -3256,8 +3256,8 @@
         </p:nvSpPr>
         <p:spPr>
           <a:xfrm>
-            <a:off x="1080000" y="3528000"/>
-            <a:ext cx="12600000" cy="360000"/>
+            <a:off x="1080000" y="3708000"/>
+            <a:ext cx="14400000" cy="360000"/>
           </a:xfrm>
           <a:prstGeom prst="rect">
             <a:avLst/>
@@ -3271,14 +3271,14 @@
           <a:lstStyle/>
           <a:p>
             <a:pPr algn="l">
-              <a:defRPr sz="2000" b="1">
+              <a:defRPr sz="1800" b="1">
                 <a:solidFill>
                   <a:srgbClr val="2C3E50"/>
                 </a:solidFill>
               </a:defRPr>
             </a:pPr>
             <a:r>
-              <a:t>Background</a:t>
+              <a:t>1.  Project Overview</a:t>
             </a:r>
           </a:p>
         </p:txBody>
@@ -3291,8 +3291,8 @@
         </p:nvSpPr>
         <p:spPr>
           <a:xfrm>
-            <a:off x="1080000" y="3960000"/>
-            <a:ext cx="12600000" cy="2520000"/>
+            <a:off x="1080000" y="4320000"/>
+            <a:ext cx="14400000" cy="3600000"/>
           </a:xfrm>
           <a:prstGeom prst="rect">
             <a:avLst/>
@@ -3306,44 +3306,49 @@
           <a:lstStyle/>
           <a:p>
             <a:pPr algn="l">
-              <a:defRPr sz="1200" b="0">
+              <a:defRPr sz="1100" b="0">
                 <a:solidFill>
                   <a:srgbClr val="2C3E50"/>
                 </a:solidFill>
               </a:defRPr>
             </a:pPr>
             <a:r>
-              <a:t>Spatial transcriptomics enables gene expression profiling within</a:t>
-            </a:r>
-            <a:br/>
-            <a:r>
-              <a:t>native tissue context. SubCellSpace builds a comprehensive,</a:t>
-            </a:r>
-            <a:br/>
-            <a:r>
-              <a:t>scverse-native database from three major platforms:</a:t>
-            </a:r>
-            <a:br/>
-            <a:br/>
-            <a:r>
-              <a:t>  • NanoString CosMx — High-plex in situ RNA detection</a:t>
-            </a:r>
-            <a:br/>
-            <a:r>
-              <a:t>  • 10x Genomics Xenium — Subcellular + multimodal imaging</a:t>
-            </a:r>
-            <a:br/>
-            <a:r>
-              <a:t>  • Vizgen MERFISH — Multiplexed FISH, ultra-high plexity</a:t>
-            </a:r>
-            <a:br/>
-            <a:br/>
-            <a:r>
-              <a:t>All data processed through a unified 6-step pipeline with</a:t>
-            </a:r>
-            <a:br/>
-            <a:r>
-              <a:t>21 standardized metadata columns per entry.</a:t>
+              <a:t>SubCellSpace is a comprehensive subcellular spatial transcriptomics</a:t>
+            </a:r>
+            <a:br/>
+            <a:r>
+              <a:t>analysis platform. It integrates three key components:</a:t>
+            </a:r>
+            <a:br/>
+            <a:br/>
+            <a:r>
+              <a:t>  • scverse-native analysis pipeline (6 steps)</a:t>
+            </a:r>
+            <a:br/>
+            <a:r>
+              <a:t>  • GEO database with 2,131 curated datasets</a:t>
+            </a:r>
+            <a:br/>
+            <a:r>
+              <a:t>  • Static web browser for data exploration</a:t>
+            </a:r>
+            <a:br/>
+            <a:br/>
+            <a:r>
+              <a:t>Platforms supported:</a:t>
+            </a:r>
+            <a:br/>
+            <a:r>
+              <a:t>  NanoString CosMx  |  10x Genomics Xenium  |  Vizgen MERFISH</a:t>
+            </a:r>
+            <a:br/>
+            <a:br/>
+            <a:r>
+              <a:t>All processing is unified under a single YAML config file,</a:t>
+            </a:r>
+            <a:br/>
+            <a:r>
+              <a:t>with plugin-style backends for each pipeline step.</a:t>
             </a:r>
           </a:p>
         </p:txBody>
@@ -3356,8 +3361,8 @@
         </p:nvSpPr>
         <p:spPr>
           <a:xfrm>
-            <a:off x="720000" y="18720000"/>
-            <a:ext cx="13320000" cy="12240000"/>
+            <a:off x="16560000" y="3600000"/>
+            <a:ext cx="15120000" cy="4680000"/>
           </a:xfrm>
           <a:prstGeom prst="roundRect">
             <a:avLst/>
@@ -3399,8 +3404,8 @@
         </p:nvSpPr>
         <p:spPr>
           <a:xfrm>
-            <a:off x="1080000" y="18828000"/>
-            <a:ext cx="12600000" cy="360000"/>
+            <a:off x="16920000" y="3708000"/>
+            <a:ext cx="14400000" cy="360000"/>
           </a:xfrm>
           <a:prstGeom prst="rect">
             <a:avLst/>
@@ -3414,14 +3419,14 @@
           <a:lstStyle/>
           <a:p>
             <a:pPr algn="l">
-              <a:defRPr sz="2000" b="1">
+              <a:defRPr sz="1800" b="1">
                 <a:solidFill>
                   <a:srgbClr val="2C3E50"/>
                 </a:solidFill>
               </a:defRPr>
             </a:pPr>
             <a:r>
-              <a:t>Data Processing Pipeline</a:t>
+              <a:t>2.  Analysis Pipeline</a:t>
             </a:r>
           </a:p>
         </p:txBody>
@@ -3442,8 +3447,8 @@
         </p:blipFill>
         <p:spPr>
           <a:xfrm>
-            <a:off x="900000" y="19440000"/>
-            <a:ext cx="12960000" cy="5040000"/>
+            <a:off x="16740000" y="4500000"/>
+            <a:ext cx="14760000" cy="3420000"/>
           </a:xfrm>
           <a:prstGeom prst="rect">
             <a:avLst/>
@@ -3458,14 +3463,14 @@
         </p:nvSpPr>
         <p:spPr>
           <a:xfrm>
-            <a:off x="900000" y="24660000"/>
-            <a:ext cx="12960000" cy="5760000"/>
+            <a:off x="720000" y="8640000"/>
+            <a:ext cx="15120000" cy="8640000"/>
           </a:xfrm>
           <a:prstGeom prst="roundRect">
             <a:avLst/>
           </a:prstGeom>
           <a:solidFill>
-            <a:srgbClr val="E8F8F0"/>
+            <a:srgbClr val="E8F0FE"/>
           </a:solidFill>
           <a:ln>
             <a:noFill/>
@@ -3501,8 +3506,8 @@
         </p:nvSpPr>
         <p:spPr>
           <a:xfrm>
-            <a:off x="1260000" y="24840000"/>
-            <a:ext cx="12600000" cy="5400000"/>
+            <a:off x="1080000" y="8748000"/>
+            <a:ext cx="14400000" cy="360000"/>
           </a:xfrm>
           <a:prstGeom prst="rect">
             <a:avLst/>
@@ -3516,66 +3521,130 @@
           <a:lstStyle/>
           <a:p>
             <a:pPr algn="l">
-              <a:defRPr sz="1200" b="0">
+              <a:defRPr sz="1800" b="1">
                 <a:solidFill>
                   <a:srgbClr val="2C3E50"/>
                 </a:solidFill>
               </a:defRPr>
             </a:pPr>
             <a:r>
-              <a:t>Database Summary</a:t>
-            </a:r>
-            <a:br/>
-            <a:br/>
-            <a:r>
-              <a:t>Total datasets indexed:      2,131</a:t>
-            </a:r>
-            <a:br/>
-            <a:r>
-              <a:t>Ready for analysis:            1,019</a:t>
-            </a:r>
-            <a:br/>
-            <a:r>
-              <a:t>Pending download:             1,055</a:t>
-            </a:r>
-            <a:br/>
-            <a:r>
-              <a:t>Platform breakdown:</a:t>
-            </a:r>
-            <a:br/>
-            <a:r>
-              <a:t>  CosMx   476  (186 ready)</a:t>
-            </a:r>
-            <a:br/>
-            <a:r>
-              <a:t>  Xenium  1,525 (717 ready)</a:t>
-            </a:r>
-            <a:br/>
-            <a:r>
-              <a:t>  MERFISH 130   (116 ready)</a:t>
-            </a:r>
-            <a:br/>
-            <a:br/>
-            <a:r>
-              <a:t>Each entry: 21 columns (GEO metadata,</a:t>
-            </a:r>
-            <a:br/>
-            <a:r>
-              <a:t>LLM annotation, file info, statistics)</a:t>
-            </a:r>
-          </a:p>
-        </p:txBody>
-      </p:sp>
-      <p:sp>
-        <p:nvSpPr>
-          <p:cNvPr id="13" name="Rounded Rectangle 12"/>
+              <a:t>3.  Pipeline Steps &amp; Backends</a:t>
+            </a:r>
+          </a:p>
+        </p:txBody>
+      </p:sp>
+      <p:sp>
+        <p:nvSpPr>
+          <p:cNvPr id="13" name="TextBox 12"/>
+          <p:cNvSpPr txBox="1"/>
+          <p:nvPr/>
+        </p:nvSpPr>
+        <p:spPr>
+          <a:xfrm>
+            <a:off x="1080000" y="9360000"/>
+            <a:ext cx="14400000" cy="7560000"/>
+          </a:xfrm>
+          <a:prstGeom prst="rect">
+            <a:avLst/>
+          </a:prstGeom>
+          <a:noFill/>
+        </p:spPr>
+        <p:txBody>
+          <a:bodyPr wrap="square">
+            <a:spAutoFit/>
+          </a:bodyPr>
+          <a:lstStyle/>
+          <a:p>
+            <a:pPr algn="l">
+              <a:defRPr sz="1000" b="0">
+                <a:solidFill>
+                  <a:srgbClr val="2C3E50"/>
+                </a:solidFill>
+              </a:defRPr>
+            </a:pPr>
+            <a:r>
+              <a:t>Step 1 — Denoise:  Filter low-quality transcripts &amp; cells</a:t>
+            </a:r>
+            <a:br/>
+            <a:r>
+              <a:t>   Backends: basic, sparc</a:t>
+            </a:r>
+            <a:br/>
+            <a:br/>
+            <a:r>
+              <a:t>Step 2 — Patchify:  Split large tissue into spatial patches</a:t>
+            </a:r>
+            <a:br/>
+            <a:r>
+              <a:t>   Backends: grid, hex</a:t>
+            </a:r>
+            <a:br/>
+            <a:br/>
+            <a:r>
+              <a:t>Step 3 — Segmentation:  Assign transcripts to cells</a:t>
+            </a:r>
+            <a:br/>
+            <a:r>
+              <a:t>   Backends: fov_cell_id, cellpose, baysor, proseg, comseg</a:t>
+            </a:r>
+            <a:br/>
+            <a:br/>
+            <a:r>
+              <a:t>Step 4 — Clustering:  Unsupervised cell clustering</a:t>
+            </a:r>
+            <a:br/>
+            <a:r>
+              <a:t>   Backends: leiden, louvain</a:t>
+            </a:r>
+            <a:br/>
+            <a:br/>
+            <a:r>
+              <a:t>Step 5 — Annotation:  Cell type annotation</a:t>
+            </a:r>
+            <a:br/>
+            <a:r>
+              <a:t>   Backends: celltypist, scrin</a:t>
+            </a:r>
+            <a:br/>
+            <a:br/>
+            <a:r>
+              <a:t>Step 6 — Spatial Analysis:  Spatial autocorrelation</a:t>
+            </a:r>
+            <a:br/>
+            <a:r>
+              <a:t>   Backends: moran, geary</a:t>
+            </a:r>
+            <a:br/>
+            <a:br/>
+            <a:r>
+              <a:t>Subcellular Analysis:  RNA localization &amp; domain detection</a:t>
+            </a:r>
+            <a:br/>
+            <a:r>
+              <a:t>   Backends: scrin, hdbscan, dbscan, phenograph</a:t>
+            </a:r>
+            <a:br/>
+            <a:br/>
+            <a:r>
+              <a:t>All backends are registered via @register_backend decorator</a:t>
+            </a:r>
+            <a:br/>
+            <a:r>
+              <a:t>and selected through config/pipeline.yaml</a:t>
+            </a:r>
+          </a:p>
+        </p:txBody>
+      </p:sp>
+      <p:sp>
+        <p:nvSpPr>
+          <p:cNvPr id="14" name="Rounded Rectangle 13"/>
           <p:cNvSpPr/>
           <p:nvPr/>
         </p:nvSpPr>
         <p:spPr>
           <a:xfrm>
-            <a:off x="14760000" y="3420000"/>
-            <a:ext cx="13320000" cy="13680000"/>
+            <a:off x="16560000" y="8640000"/>
+            <a:ext cx="15120000" cy="8640000"/>
           </a:xfrm>
           <a:prstGeom prst="roundRect">
             <a:avLst/>
@@ -3611,14 +3680,14 @@
       </p:sp>
       <p:sp>
         <p:nvSpPr>
-          <p:cNvPr id="14" name="TextBox 13"/>
+          <p:cNvPr id="15" name="TextBox 14"/>
           <p:cNvSpPr txBox="1"/>
           <p:nvPr/>
         </p:nvSpPr>
         <p:spPr>
           <a:xfrm>
-            <a:off x="15120000" y="3528000"/>
-            <a:ext cx="12600000" cy="360000"/>
+            <a:off x="16920000" y="8748000"/>
+            <a:ext cx="14400000" cy="360000"/>
           </a:xfrm>
           <a:prstGeom prst="rect">
             <a:avLst/>
@@ -3632,21 +3701,21 @@
           <a:lstStyle/>
           <a:p>
             <a:pPr algn="l">
-              <a:defRPr sz="2000" b="1">
+              <a:defRPr sz="1800" b="1">
                 <a:solidFill>
                   <a:srgbClr val="2C3E50"/>
                 </a:solidFill>
               </a:defRPr>
             </a:pPr>
             <a:r>
-              <a:t>Database Scale &amp; Data Enrichment</a:t>
+              <a:t>4.  GEO Database System</a:t>
             </a:r>
           </a:p>
         </p:txBody>
       </p:sp>
       <p:pic>
         <p:nvPicPr>
-          <p:cNvPr id="15" name="Picture 14" descr="fig1_overview.png"/>
+          <p:cNvPr id="16" name="Picture 15" descr="fig1_overview.png"/>
           <p:cNvPicPr>
             <a:picLocks noChangeAspect="1"/>
           </p:cNvPicPr>
@@ -3660,8 +3729,8 @@
         </p:blipFill>
         <p:spPr>
           <a:xfrm>
-            <a:off x="14868000" y="4068000"/>
-            <a:ext cx="13104000" cy="12600000"/>
+            <a:off x="16632000" y="9360000"/>
+            <a:ext cx="14976000" cy="3960000"/>
           </a:xfrm>
           <a:prstGeom prst="rect">
             <a:avLst/>
@@ -3670,14 +3739,83 @@
       </p:pic>
       <p:sp>
         <p:nvSpPr>
-          <p:cNvPr id="16" name="Rounded Rectangle 15"/>
+          <p:cNvPr id="17" name="TextBox 16"/>
+          <p:cNvSpPr txBox="1"/>
+          <p:nvPr/>
+        </p:nvSpPr>
+        <p:spPr>
+          <a:xfrm>
+            <a:off x="16920000" y="13500000"/>
+            <a:ext cx="14400000" cy="3420000"/>
+          </a:xfrm>
+          <a:prstGeom prst="rect">
+            <a:avLst/>
+          </a:prstGeom>
+          <a:noFill/>
+        </p:spPr>
+        <p:txBody>
+          <a:bodyPr wrap="square">
+            <a:spAutoFit/>
+          </a:bodyPr>
+          <a:lstStyle/>
+          <a:p>
+            <a:pPr algn="l">
+              <a:defRPr sz="1100" b="0">
+                <a:solidFill>
+                  <a:srgbClr val="2C3E50"/>
+                </a:solidFill>
+              </a:defRPr>
+            </a:pPr>
+            <a:r>
+              <a:t>Dual database architecture:</a:t>
+            </a:r>
+            <a:br/>
+            <a:r>
+              <a:t>  • datasets.csv: Legacy non-GEO metadata (998 rows)</a:t>
+            </a:r>
+            <a:br/>
+            <a:r>
+              <a:t>  • *_geo.csv: Per-platform GEO entries (2,131 rows)</a:t>
+            </a:r>
+            <a:br/>
+            <a:br/>
+            <a:r>
+              <a:t>4-step enrichment pipeline:</a:t>
+            </a:r>
+            <a:br/>
+            <a:r>
+              <a:t>  1. GEO Crawl — NCBI E-utilities API → GSE metadata</a:t>
+            </a:r>
+            <a:br/>
+            <a:r>
+              <a:t>  2. LLM Annotation — DeepSeek → tissue + disease_state</a:t>
+            </a:r>
+            <a:br/>
+            <a:r>
+              <a:t>  3. File Integrity — Touch module → available_files</a:t>
+            </a:r>
+            <a:br/>
+            <a:r>
+              <a:t>  4. Streaming Stats — Count tx / cells / genes</a:t>
+            </a:r>
+            <a:br/>
+            <a:br/>
+            <a:r>
+              <a:t>21 standardized columns per dataset entry</a:t>
+            </a:r>
+          </a:p>
+        </p:txBody>
+      </p:sp>
+      <p:sp>
+        <p:nvSpPr>
+          <p:cNvPr id="18" name="Rounded Rectangle 17"/>
           <p:cNvSpPr/>
           <p:nvPr/>
         </p:nvSpPr>
         <p:spPr>
           <a:xfrm>
-            <a:off x="14760000" y="18720000"/>
-            <a:ext cx="13320000" cy="12240000"/>
+            <a:off x="720000" y="17640000"/>
+            <a:ext cx="15120000" cy="10800000"/>
           </a:xfrm>
           <a:prstGeom prst="roundRect">
             <a:avLst/>
@@ -3713,14 +3851,14 @@
       </p:sp>
       <p:sp>
         <p:nvSpPr>
-          <p:cNvPr id="17" name="TextBox 16"/>
+          <p:cNvPr id="19" name="TextBox 18"/>
           <p:cNvSpPr txBox="1"/>
           <p:nvPr/>
         </p:nvSpPr>
         <p:spPr>
           <a:xfrm>
-            <a:off x="15120000" y="18828000"/>
-            <a:ext cx="12600000" cy="360000"/>
+            <a:off x="1080000" y="17748000"/>
+            <a:ext cx="14400000" cy="360000"/>
           </a:xfrm>
           <a:prstGeom prst="rect">
             <a:avLst/>
@@ -3734,21 +3872,21 @@
           <a:lstStyle/>
           <a:p>
             <a:pPr algn="l">
-              <a:defRPr sz="2000" b="1">
+              <a:defRPr sz="1800" b="1">
                 <a:solidFill>
                   <a:srgbClr val="2C3E50"/>
                 </a:solidFill>
               </a:defRPr>
             </a:pPr>
             <a:r>
-              <a:t>Companion File Availability</a:t>
+              <a:t>5.  Database Statistics</a:t>
             </a:r>
           </a:p>
         </p:txBody>
       </p:sp>
       <p:pic>
         <p:nvPicPr>
-          <p:cNvPr id="18" name="Picture 17" descr="fig2_optional_files.png"/>
+          <p:cNvPr id="20" name="Picture 19" descr="fig3_tissue_disease.png"/>
           <p:cNvPicPr>
             <a:picLocks noChangeAspect="1"/>
           </p:cNvPicPr>
@@ -3762,24 +3900,48 @@
         </p:blipFill>
         <p:spPr>
           <a:xfrm>
-            <a:off x="14868000" y="19368000"/>
-            <a:ext cx="13104000" cy="11160000"/>
+            <a:off x="828000" y="18360000"/>
+            <a:ext cx="14904000" cy="5040000"/>
           </a:xfrm>
           <a:prstGeom prst="rect">
             <a:avLst/>
           </a:prstGeom>
         </p:spPr>
       </p:pic>
-      <p:sp>
-        <p:nvSpPr>
-          <p:cNvPr id="19" name="Rounded Rectangle 18"/>
+      <p:pic>
+        <p:nvPicPr>
+          <p:cNvPr id="21" name="Picture 20" descr="fig4_stats_summary.png"/>
+          <p:cNvPicPr>
+            <a:picLocks noChangeAspect="1"/>
+          </p:cNvPicPr>
+          <p:nvPr/>
+        </p:nvPicPr>
+        <p:blipFill>
+          <a:blip r:embed="rId5"/>
+          <a:stretch>
+            <a:fillRect/>
+          </a:stretch>
+        </p:blipFill>
+        <p:spPr>
+          <a:xfrm>
+            <a:off x="828000" y="23760000"/>
+            <a:ext cx="14904000" cy="4320000"/>
+          </a:xfrm>
+          <a:prstGeom prst="rect">
+            <a:avLst/>
+          </a:prstGeom>
+        </p:spPr>
+      </p:pic>
+      <p:sp>
+        <p:nvSpPr>
+          <p:cNvPr id="22" name="Rounded Rectangle 21"/>
           <p:cNvSpPr/>
           <p:nvPr/>
         </p:nvSpPr>
         <p:spPr>
           <a:xfrm>
-            <a:off x="28800000" y="3420000"/>
-            <a:ext cx="13320000" cy="13680000"/>
+            <a:off x="16560000" y="17640000"/>
+            <a:ext cx="15120000" cy="10800000"/>
           </a:xfrm>
           <a:prstGeom prst="roundRect">
             <a:avLst/>
@@ -3815,14 +3977,14 @@
       </p:sp>
       <p:sp>
         <p:nvSpPr>
-          <p:cNvPr id="20" name="TextBox 19"/>
+          <p:cNvPr id="23" name="TextBox 22"/>
           <p:cNvSpPr txBox="1"/>
           <p:nvPr/>
         </p:nvSpPr>
         <p:spPr>
           <a:xfrm>
-            <a:off x="29160000" y="3528000"/>
-            <a:ext cx="12600000" cy="360000"/>
+            <a:off x="16920000" y="17748000"/>
+            <a:ext cx="14400000" cy="360000"/>
           </a:xfrm>
           <a:prstGeom prst="rect">
             <a:avLst/>
@@ -3836,36 +3998,36 @@
           <a:lstStyle/>
           <a:p>
             <a:pPr algn="l">
-              <a:defRPr sz="2000" b="1">
+              <a:defRPr sz="1800" b="1">
                 <a:solidFill>
                   <a:srgbClr val="2C3E50"/>
                 </a:solidFill>
               </a:defRPr>
             </a:pPr>
             <a:r>
-              <a:t>Biological Coverage</a:t>
+              <a:t>6.  File Coverage &amp; Frontend</a:t>
             </a:r>
           </a:p>
         </p:txBody>
       </p:sp>
       <p:pic>
         <p:nvPicPr>
-          <p:cNvPr id="21" name="Picture 20" descr="fig3_tissue_disease.png"/>
+          <p:cNvPr id="24" name="Picture 23" descr="fig2_optional_files.png"/>
           <p:cNvPicPr>
             <a:picLocks noChangeAspect="1"/>
           </p:cNvPicPr>
           <p:nvPr/>
         </p:nvPicPr>
         <p:blipFill>
-          <a:blip r:embed="rId5"/>
+          <a:blip r:embed="rId6"/>
           <a:stretch>
             <a:fillRect/>
           </a:stretch>
         </p:blipFill>
         <p:spPr>
           <a:xfrm>
-            <a:off x="28908000" y="4068000"/>
-            <a:ext cx="13104000" cy="12600000"/>
+            <a:off x="16668000" y="18360000"/>
+            <a:ext cx="14904000" cy="4680000"/>
           </a:xfrm>
           <a:prstGeom prst="rect">
             <a:avLst/>
@@ -3874,20 +4036,101 @@
       </p:pic>
       <p:sp>
         <p:nvSpPr>
-          <p:cNvPr id="22" name="Rounded Rectangle 21"/>
+          <p:cNvPr id="25" name="TextBox 24"/>
+          <p:cNvSpPr txBox="1"/>
+          <p:nvPr/>
+        </p:nvSpPr>
+        <p:spPr>
+          <a:xfrm>
+            <a:off x="16920000" y="23220000"/>
+            <a:ext cx="14400000" cy="5040000"/>
+          </a:xfrm>
+          <a:prstGeom prst="rect">
+            <a:avLst/>
+          </a:prstGeom>
+          <a:noFill/>
+        </p:spPr>
+        <p:txBody>
+          <a:bodyPr wrap="square">
+            <a:spAutoFit/>
+          </a:bodyPr>
+          <a:lstStyle/>
+          <a:p>
+            <a:pPr algn="l">
+              <a:defRPr sz="1000" b="0">
+                <a:solidFill>
+                  <a:srgbClr val="2C3E50"/>
+                </a:solidFill>
+              </a:defRPr>
+            </a:pPr>
+            <a:r>
+              <a:t>Companion file types tracked per platform:</a:t>
+            </a:r>
+            <a:br/>
+            <a:br/>
+            <a:r>
+              <a:t>CosMx:  polygons, expr_matrix, cell_metadata, fov_positions</a:t>
+            </a:r>
+            <a:br/>
+            <a:r>
+              <a:t>Xenium: cell_boundaries, nucleus_boundaries,</a:t>
+            </a:r>
+            <a:br/>
+            <a:r>
+              <a:t>        expr_matrix (h5/mtx), cell_metadata, gene_panel</a:t>
+            </a:r>
+            <a:br/>
+            <a:r>
+              <a:t>MERFISH: expr_matrix, cell_metadata</a:t>
+            </a:r>
+            <a:br/>
+            <a:br/>
+            <a:r>
+              <a:t>Frontend: Pure static React browser</a:t>
+            </a:r>
+            <a:br/>
+            <a:r>
+              <a:t>  • Platform tabs (CosMx / Xenium / MERFISH)</a:t>
+            </a:r>
+            <a:br/>
+            <a:r>
+              <a:t>  • 21-column sortable table with category headers</a:t>
+            </a:r>
+            <a:br/>
+            <a:r>
+              <a:t>  • Full-text search + status filtering</a:t>
+            </a:r>
+            <a:br/>
+            <a:r>
+              <a:t>  • GEO hyperlinks, row detail modals</a:t>
+            </a:r>
+            <a:br/>
+            <a:r>
+              <a:t>  • Pagination (25/50/100/All)</a:t>
+            </a:r>
+            <a:br/>
+            <a:r>
+              <a:t>  • No backend required — static JSON data source</a:t>
+            </a:r>
+          </a:p>
+        </p:txBody>
+      </p:sp>
+      <p:sp>
+        <p:nvSpPr>
+          <p:cNvPr id="26" name="Rounded Rectangle 25"/>
           <p:cNvSpPr/>
           <p:nvPr/>
         </p:nvSpPr>
         <p:spPr>
           <a:xfrm>
-            <a:off x="28800000" y="18720000"/>
-            <a:ext cx="13320000" cy="12240000"/>
+            <a:off x="720000" y="28800000"/>
+            <a:ext cx="30960000" cy="5400000"/>
           </a:xfrm>
           <a:prstGeom prst="roundRect">
             <a:avLst/>
           </a:prstGeom>
           <a:solidFill>
-            <a:srgbClr val="FFFFFF"/>
+            <a:srgbClr val="FEF3E8"/>
           </a:solidFill>
           <a:ln>
             <a:noFill/>
@@ -3917,14 +4160,14 @@
       </p:sp>
       <p:sp>
         <p:nvSpPr>
-          <p:cNvPr id="23" name="TextBox 22"/>
+          <p:cNvPr id="27" name="TextBox 26"/>
           <p:cNvSpPr txBox="1"/>
           <p:nvPr/>
         </p:nvSpPr>
         <p:spPr>
           <a:xfrm>
-            <a:off x="29160000" y="18828000"/>
-            <a:ext cx="12600000" cy="360000"/>
+            <a:off x="1080000" y="28908000"/>
+            <a:ext cx="30240000" cy="360000"/>
           </a:xfrm>
           <a:prstGeom prst="rect">
             <a:avLst/>
@@ -3938,52 +4181,185 @@
           <a:lstStyle/>
           <a:p>
             <a:pPr algn="l">
-              <a:defRPr sz="2000" b="1">
+              <a:defRPr sz="1800" b="1">
                 <a:solidFill>
                   <a:srgbClr val="2C3E50"/>
                 </a:solidFill>
               </a:defRPr>
             </a:pPr>
             <a:r>
-              <a:t>Dataset Statistics (CosMx)</a:t>
-            </a:r>
-          </a:p>
-        </p:txBody>
-      </p:sp>
-      <p:pic>
-        <p:nvPicPr>
-          <p:cNvPr id="24" name="Picture 23" descr="fig4_stats_summary.png"/>
-          <p:cNvPicPr>
-            <a:picLocks noChangeAspect="1"/>
-          </p:cNvPicPr>
+              <a:t>7.  System Architecture &amp; Tools</a:t>
+            </a:r>
+          </a:p>
+        </p:txBody>
+      </p:sp>
+      <p:sp>
+        <p:nvSpPr>
+          <p:cNvPr id="28" name="TextBox 27"/>
+          <p:cNvSpPr txBox="1"/>
           <p:nvPr/>
-        </p:nvPicPr>
-        <p:blipFill>
-          <a:blip r:embed="rId6"/>
-          <a:stretch>
-            <a:fillRect/>
-          </a:stretch>
-        </p:blipFill>
-        <p:spPr>
-          <a:xfrm>
-            <a:off x="28908000" y="19368000"/>
-            <a:ext cx="13104000" cy="11160000"/>
+        </p:nvSpPr>
+        <p:spPr>
+          <a:xfrm>
+            <a:off x="1080000" y="29520000"/>
+            <a:ext cx="14760000" cy="4320000"/>
           </a:xfrm>
           <a:prstGeom prst="rect">
             <a:avLst/>
           </a:prstGeom>
-        </p:spPr>
-      </p:pic>
-      <p:sp>
-        <p:nvSpPr>
-          <p:cNvPr id="25" name="Rounded Rectangle 24"/>
+          <a:noFill/>
+        </p:spPr>
+        <p:txBody>
+          <a:bodyPr wrap="square">
+            <a:spAutoFit/>
+          </a:bodyPr>
+          <a:lstStyle/>
+          <a:p>
+            <a:pPr algn="l">
+              <a:defRPr sz="1000" b="0">
+                <a:solidFill>
+                  <a:srgbClr val="2C3E50"/>
+                </a:solidFill>
+              </a:defRPr>
+            </a:pPr>
+            <a:r>
+              <a:t>Core Stack:</a:t>
+            </a:r>
+            <a:br/>
+            <a:r>
+              <a:t>  • Python 3.12 + scverse ecosystem</a:t>
+            </a:r>
+            <a:br/>
+            <a:r>
+              <a:t>    (scanpy, squidpy, spatialdata, anndata)</a:t>
+            </a:r>
+            <a:br/>
+            <a:r>
+              <a:t>  • FastAPI server for database CRUD</a:t>
+            </a:r>
+            <a:br/>
+            <a:r>
+              <a:t>  • React 18 + TypeScript + Vite frontend</a:t>
+            </a:r>
+            <a:br/>
+            <a:r>
+              <a:t>  • Slurm HPC job arrays for batch processing</a:t>
+            </a:r>
+            <a:br/>
+            <a:br/>
+            <a:r>
+              <a:t>Output Formats:</a:t>
+            </a:r>
+            <a:br/>
+            <a:r>
+              <a:t>  • cells.parquet + metadata.json  (container export)</a:t>
+            </a:r>
+            <a:br/>
+            <a:r>
+              <a:t>  • subcellspace_report.html  (interactive HTML report)</a:t>
+            </a:r>
+            <a:br/>
+            <a:r>
+              <a:t>  • subcellspace_results.h5ad  (full AnnData)</a:t>
+            </a:r>
+            <a:br/>
+            <a:r>
+              <a:t>  • subcellspace_touch_report.json  (file integrity)</a:t>
+            </a:r>
+          </a:p>
+        </p:txBody>
+      </p:sp>
+      <p:sp>
+        <p:nvSpPr>
+          <p:cNvPr id="29" name="TextBox 28"/>
+          <p:cNvSpPr txBox="1"/>
+          <p:nvPr/>
+        </p:nvSpPr>
+        <p:spPr>
+          <a:xfrm>
+            <a:off x="16920000" y="29520000"/>
+            <a:ext cx="14760000" cy="4320000"/>
+          </a:xfrm>
+          <a:prstGeom prst="rect">
+            <a:avLst/>
+          </a:prstGeom>
+          <a:noFill/>
+        </p:spPr>
+        <p:txBody>
+          <a:bodyPr wrap="square">
+            <a:spAutoFit/>
+          </a:bodyPr>
+          <a:lstStyle/>
+          <a:p>
+            <a:pPr algn="l">
+              <a:defRPr sz="1000" b="0">
+                <a:solidFill>
+                  <a:srgbClr val="2C3E50"/>
+                </a:solidFill>
+              </a:defRPr>
+            </a:pPr>
+            <a:r>
+              <a:t>External Tools:</a:t>
+            </a:r>
+            <a:br/>
+            <a:r>
+              <a:t>  • SCRIN — Subcellular RNA localization &amp; interactivity</a:t>
+            </a:r>
+            <a:br/>
+            <a:r>
+              <a:t>  • SOPA — Segmentation pipeline (Cellpose, Baysor, etc.)</a:t>
+            </a:r>
+            <a:br/>
+            <a:br/>
+            <a:r>
+              <a:t>Infrastructure:</a:t>
+            </a:r>
+            <a:br/>
+            <a:r>
+              <a:t>  • a-cluster (192.168.1.2, 377GB RAM, 80 CPU)</a:t>
+            </a:r>
+            <a:br/>
+            <a:r>
+              <a:t>  • gpu01 — NVIDIA GPU node for segmentation</a:t>
+            </a:r>
+            <a:br/>
+            <a:r>
+              <a:t>  • bio-download jumpbox for GEO data transfer</a:t>
+            </a:r>
+            <a:br/>
+            <a:r>
+              <a:t>  • /data3/yangxr002/ — 218TB shared storage</a:t>
+            </a:r>
+            <a:br/>
+            <a:br/>
+            <a:r>
+              <a:t>Data Processing:</a:t>
+            </a:r>
+            <a:br/>
+            <a:r>
+              <a:t>  • 3+ million transcripts streamed per dataset</a:t>
+            </a:r>
+            <a:br/>
+            <a:r>
+              <a:t>  • Zero I/O-load streaming statistics module</a:t>
+            </a:r>
+            <a:br/>
+            <a:r>
+              <a:t>  • Incremental checkpoint saves for batch runs</a:t>
+            </a:r>
+          </a:p>
+        </p:txBody>
+      </p:sp>
+      <p:sp>
+        <p:nvSpPr>
+          <p:cNvPr id="30" name="Rounded Rectangle 29"/>
           <p:cNvSpPr/>
           <p:nvPr/>
         </p:nvSpPr>
         <p:spPr>
           <a:xfrm>
-            <a:off x="720000" y="31320000"/>
-            <a:ext cx="41760000" cy="900000"/>
+            <a:off x="720000" y="34560000"/>
+            <a:ext cx="30960000" cy="900000"/>
           </a:xfrm>
           <a:prstGeom prst="roundRect">
             <a:avLst/>
@@ -4019,14 +4395,14 @@
       </p:sp>
       <p:sp>
         <p:nvSpPr>
-          <p:cNvPr id="26" name="TextBox 25"/>
+          <p:cNvPr id="31" name="TextBox 30"/>
           <p:cNvSpPr txBox="1"/>
           <p:nvPr/>
         </p:nvSpPr>
         <p:spPr>
           <a:xfrm>
-            <a:off x="1440000" y="31500000"/>
-            <a:ext cx="40320000" cy="540000"/>
+            <a:off x="1440000" y="34740000"/>
+            <a:ext cx="29520000" cy="540000"/>
           </a:xfrm>
           <a:prstGeom prst="rect">
             <a:avLst/>

</xml_diff>